<commit_message>
Machines: slides with reference values, an executive summary and slide-sized charts drawn from the results
</commit_message>
<xml_diff>
--- a/examples/electrodynamics/results/18_emachine_slides.pptx
+++ b/examples/electrodynamics/results/18_emachine_slides.pptx
@@ -16,6 +16,7 @@
     <p:sldId id="264" r:id="rId15"/>
     <p:sldId id="265" r:id="rId16"/>
     <p:sldId id="266" r:id="rId17"/>
+    <p:sldId id="267" r:id="rId18"/>
   </p:sldIdLst>
   <p:sldSz cx="12192000" cy="6858000" type="screen4x3"/>
   <p:notesSz cx="6858000" cy="9144000"/>
@@ -3106,8 +3107,8 @@
         </p:nvSpPr>
         <p:spPr>
           <a:xfrm>
-            <a:off x="400000" y="250000"/>
-            <a:ext cx="11392000" cy="700000"/>
+            <a:off x="411480" y="1097280"/>
+            <a:ext cx="5120640" cy="1463040"/>
           </a:xfrm>
           <a:prstGeom prst="rect">
             <a:avLst/>
@@ -3115,14 +3116,30 @@
           <a:noFill/>
         </p:spPr>
         <p:txBody>
-          <a:bodyPr wrap="none">
+          <a:bodyPr wrap="square">
             <a:spAutoFit/>
           </a:bodyPr>
           <a:lstStyle/>
           <a:p>
-            <a:r>
-              <a:rPr sz="2600" b="1"/>
-              <a:t>2004 Toyota Prius traction motor: verified FEA to drive, thermal and design</a:t>
+            <a:pPr>
+              <a:spcAft>
+                <a:spcPts val="500"/>
+              </a:spcAft>
+              <a:defRPr sz="3000" i="0" b="1"/>
+            </a:pPr>
+            <a:r>
+              <a:t>2004 Toyota Prius traction motor</a:t>
+            </a:r>
+          </a:p>
+          <a:p>
+            <a:pPr>
+              <a:spcAft>
+                <a:spcPts val="500"/>
+              </a:spcAft>
+              <a:defRPr sz="3000" i="0" b="0"/>
+            </a:pPr>
+            <a:r>
+              <a:t>Verified FEA to drive, thermal, robustness and design</a:t>
             </a:r>
           </a:p>
         </p:txBody>
@@ -3135,8 +3152,8 @@
         </p:nvSpPr>
         <p:spPr>
           <a:xfrm>
-            <a:off x="400000" y="1000000"/>
-            <a:ext cx="6571360" cy="4958000"/>
+            <a:off x="411480" y="3017520"/>
+            <a:ext cx="5120640" cy="2377440"/>
           </a:xfrm>
           <a:prstGeom prst="rect">
             <a:avLst/>
@@ -3151,45 +3168,34 @@
           <a:p>
             <a:pPr>
               <a:spcAft>
-                <a:spcPts val="400"/>
-              </a:spcAft>
-              <a:defRPr sz="1400"/>
-            </a:pPr>
-            <a:r>
-              <a:t>Open-source chain in PINNeAPPle (pinneapple_simulation.electromagnetics.machines):</a:t>
-            </a:r>
-          </a:p>
-          <a:p>
-            <a:pPr>
-              <a:spcAft>
-                <a:spcPts val="400"/>
-              </a:spcAft>
-              <a:defRPr sz="1400"/>
-            </a:pPr>
-            <a:r>
-              <a:t>2-D nonlinear FEA -&gt; second-code cross-check -&gt; drive (MTPA, flux weakening, WLTC) -&gt; end effects -&gt; thermal and demagnetisation -&gt; skew and tolerances -&gt; FEA + GP + NSGA-II design -&gt; exchange formats</a:t>
-            </a:r>
-          </a:p>
-          <a:p>
-            <a:pPr>
-              <a:spcAft>
-                <a:spcPts val="400"/>
-              </a:spcAft>
-              <a:defRPr sz="1400"/>
-            </a:pPr>
-            <a:r>
-              <a:t>Every number in these slides is a measured output of examples 10 to 17 (results/*.json), regenerated by this script.</a:t>
-            </a:r>
-          </a:p>
-          <a:p>
-            <a:pPr>
-              <a:spcAft>
-                <a:spcPts val="400"/>
-              </a:spcAft>
-              <a:defRPr sz="1400"/>
-            </a:pPr>
-            <a:r>
-              <a:t>Geometry and materials: pyleecan's Toyota_Prius.json (48 slots, 8 poles, V magnets, M400-50A).</a:t>
+                <a:spcPts val="500"/>
+              </a:spcAft>
+              <a:defRPr sz="1800" i="0" b="0"/>
+            </a:pPr>
+            <a:r>
+              <a:t>Interior-PM, 48 slots, 8 poles, V magnets</a:t>
+            </a:r>
+          </a:p>
+          <a:p>
+            <a:pPr>
+              <a:spcAft>
+                <a:spcPts val="500"/>
+              </a:spcAft>
+              <a:defRPr sz="1800" i="0" b="0"/>
+            </a:pPr>
+            <a:r>
+              <a:t>Open-source chain in PINNeAPPle</a:t>
+            </a:r>
+          </a:p>
+          <a:p>
+            <a:pPr>
+              <a:spcAft>
+                <a:spcPts val="500"/>
+              </a:spcAft>
+              <a:defRPr sz="1800" i="0" b="0"/>
+            </a:pPr>
+            <a:r>
+              <a:t>Every number from the committed results of examples 10 to 17</a:t>
             </a:r>
           </a:p>
         </p:txBody>
@@ -3210,45 +3216,14 @@
         </p:blipFill>
         <p:spPr>
           <a:xfrm>
-            <a:off x="6871360" y="1000000"/>
-            <a:ext cx="5120640" cy="4331930"/>
+            <a:off x="5760720" y="365760"/>
+            <a:ext cx="7241922" cy="6126480"/>
           </a:xfrm>
           <a:prstGeom prst="rect">
             <a:avLst/>
           </a:prstGeom>
         </p:spPr>
       </p:pic>
-      <p:sp>
-        <p:nvSpPr>
-          <p:cNvPr id="5" name="TextBox 4"/>
-          <p:cNvSpPr txBox="1"/>
-          <p:nvPr/>
-        </p:nvSpPr>
-        <p:spPr>
-          <a:xfrm>
-            <a:off x="400000" y="6108000"/>
-            <a:ext cx="11392000" cy="600000"/>
-          </a:xfrm>
-          <a:prstGeom prst="rect">
-            <a:avLst/>
-          </a:prstGeom>
-          <a:noFill/>
-        </p:spPr>
-        <p:txBody>
-          <a:bodyPr wrap="square">
-            <a:spAutoFit/>
-          </a:bodyPr>
-          <a:lstStyle/>
-          <a:p>
-            <a:pPr>
-              <a:defRPr sz="1100" i="1"/>
-            </a:pPr>
-            <a:r>
-              <a:t>Limits: a model study from public data; no test-bench measurement of this motor was available.</a:t>
-            </a:r>
-          </a:p>
-        </p:txBody>
-      </p:sp>
     </p:spTree>
   </p:cSld>
   <p:clrMapOvr>
@@ -3275,8 +3250,8 @@
         </p:nvSpPr>
         <p:spPr>
           <a:xfrm>
-            <a:off x="400000" y="250000"/>
-            <a:ext cx="11392000" cy="700000"/>
+            <a:off x="411480" y="228600"/>
+            <a:ext cx="11369040" cy="640080"/>
           </a:xfrm>
           <a:prstGeom prst="rect">
             <a:avLst/>
@@ -3284,14 +3259,19 @@
           <a:noFill/>
         </p:spPr>
         <p:txBody>
-          <a:bodyPr wrap="none">
+          <a:bodyPr wrap="square">
             <a:spAutoFit/>
           </a:bodyPr>
           <a:lstStyle/>
           <a:p>
-            <a:r>
-              <a:rPr sz="2600" b="1"/>
-              <a:t>Rotor design: FEA + Gaussian process + NSGA-II</a:t>
+            <a:pPr>
+              <a:spcAft>
+                <a:spcPts val="500"/>
+              </a:spcAft>
+              <a:defRPr sz="2800" i="0" b="1"/>
+            </a:pPr>
+            <a:r>
+              <a:t>Manufacturing tolerances</a:t>
             </a:r>
           </a:p>
         </p:txBody>
@@ -3304,8 +3284,8 @@
         </p:nvSpPr>
         <p:spPr>
           <a:xfrm>
-            <a:off x="400000" y="1000000"/>
-            <a:ext cx="11392000" cy="1570000"/>
+            <a:off x="411480" y="914400"/>
+            <a:ext cx="11369040" cy="1051560"/>
           </a:xfrm>
           <a:prstGeom prst="rect">
             <a:avLst/>
@@ -3320,52 +3300,30 @@
           <a:p>
             <a:pPr>
               <a:spcAft>
-                <a:spcPts val="400"/>
-              </a:spcAft>
-              <a:defRPr sz="1400"/>
-            </a:pPr>
-            <a:r>
-              <a:t>Five rotor variables, maximise torque, minimise magnet mass, ripple &lt;= 30 %; every front design re-evaluated by a finer FEA.</a:t>
-            </a:r>
-          </a:p>
-          <a:p>
-            <a:pPr>
-              <a:spcAft>
-                <a:spcPts val="400"/>
-              </a:spcAft>
-              <a:defRPr sz="1400"/>
-            </a:pPr>
-            <a:r>
-              <a:t>FEA calls to equal hypervolume, hybrid vs NSGA-II on the FEA: seed 0: 53 vs 711 (92.5 % saved); seed 1: 52 vs 601 (91.3 % saved); seed 2: 51 vs 605 (91.6 % saved).</a:t>
-            </a:r>
-          </a:p>
-          <a:p>
-            <a:pPr>
-              <a:spcAft>
-                <a:spcPts val="400"/>
-              </a:spcAft>
-              <a:defRPr sz="1400"/>
-            </a:pPr>
-            <a:r>
-              <a:t>Finer FEA: all front designs feasible, torque within 1.1 %, ripple up to 30 % higher (6 angles under-sample it).</a:t>
-            </a:r>
-          </a:p>
-          <a:p>
-            <a:pPr>
-              <a:spcAft>
-                <a:spcPts val="400"/>
-              </a:spcAft>
-              <a:defRPr sz="1400"/>
-            </a:pPr>
-            <a:r>
-              <a:t>Designs beating the Prius rotor sit at the 1.0 mm bridge bound.</a:t>
+                <a:spcPts val="500"/>
+              </a:spcAft>
+              <a:defRPr sz="1800" i="0" b="0"/>
+            </a:pPr>
+            <a:r>
+              <a:t>200 Monte-Carlo FEA samples (480 gap nodes; nominal 343.4 N m on that mesh, R1 at 960 nodes): torque sigma 1.96 N m (0.57 %).</a:t>
+            </a:r>
+          </a:p>
+          <a:p>
+            <a:pPr>
+              <a:spcAft>
+                <a:spcPts val="500"/>
+              </a:spcAft>
+              <a:defRPr sz="1800" i="0" b="0"/>
+            </a:pPr>
+            <a:r>
+              <a:t>Remanence drives the torque spread, the air gap the ripple spread.</a:t>
             </a:r>
           </a:p>
         </p:txBody>
       </p:sp>
       <p:pic>
         <p:nvPicPr>
-          <p:cNvPr id="4" name="Picture 3" descr="12_prius_rotor_design.png"/>
+          <p:cNvPr id="4" name="Picture 3" descr="image.png"/>
           <p:cNvPicPr>
             <a:picLocks noChangeAspect="1"/>
           </p:cNvPicPr>
@@ -3379,8 +3337,8 @@
         </p:blipFill>
         <p:spPr>
           <a:xfrm>
-            <a:off x="1476000" y="2670000"/>
-            <a:ext cx="9239999" cy="3388000"/>
+            <a:off x="533565" y="2103120"/>
+            <a:ext cx="11124869" cy="4160520"/>
           </a:xfrm>
           <a:prstGeom prst="rect">
             <a:avLst/>
@@ -3395,8 +3353,8 @@
         </p:nvSpPr>
         <p:spPr>
           <a:xfrm>
-            <a:off x="400000" y="6108000"/>
-            <a:ext cx="11392000" cy="600000"/>
+            <a:off x="411480" y="6309360"/>
+            <a:ext cx="11369040" cy="457200"/>
           </a:xfrm>
           <a:prstGeom prst="rect">
             <a:avLst/>
@@ -3410,10 +3368,17 @@
           <a:lstStyle/>
           <a:p>
             <a:pPr>
-              <a:defRPr sz="1100" i="1"/>
-            </a:pPr>
-            <a:r>
-              <a:t>Limits: no bridge stress, demagnetisation or speed constraints: shows the method and the FEA-call saving, not a better rotor.</a:t>
+              <a:spcAft>
+                <a:spcPts val="500"/>
+              </a:spcAft>
+              <a:defRPr sz="1300" i="1" b="0">
+                <a:solidFill>
+                  <a:srgbClr val="555555"/>
+                </a:solidFill>
+              </a:defRPr>
+            </a:pPr>
+            <a:r>
+              <a:t>Limits: the tolerance sigmas are assumptions, not measured spreads.</a:t>
             </a:r>
           </a:p>
         </p:txBody>
@@ -3444,8 +3409,8 @@
         </p:nvSpPr>
         <p:spPr>
           <a:xfrm>
-            <a:off x="400000" y="250000"/>
-            <a:ext cx="11392000" cy="700000"/>
+            <a:off x="411480" y="228600"/>
+            <a:ext cx="11369040" cy="640080"/>
           </a:xfrm>
           <a:prstGeom prst="rect">
             <a:avLst/>
@@ -3453,14 +3418,19 @@
           <a:noFill/>
         </p:spPr>
         <p:txBody>
-          <a:bodyPr wrap="none">
+          <a:bodyPr wrap="square">
             <a:spAutoFit/>
           </a:bodyPr>
           <a:lstStyle/>
           <a:p>
-            <a:r>
-              <a:rPr sz="2600" b="1"/>
-              <a:t>Exchange formats and limits</a:t>
+            <a:pPr>
+              <a:spcAft>
+                <a:spcPts val="500"/>
+              </a:spcAft>
+              <a:defRPr sz="2800" i="0" b="1"/>
+            </a:pPr>
+            <a:r>
+              <a:t>Rotor design: FEA + Gaussian process + NSGA-II</a:t>
             </a:r>
           </a:p>
         </p:txBody>
@@ -3473,8 +3443,8 @@
         </p:nvSpPr>
         <p:spPr>
           <a:xfrm>
-            <a:off x="400000" y="1000000"/>
-            <a:ext cx="11392000" cy="4958000"/>
+            <a:off x="411480" y="914400"/>
+            <a:ext cx="11369040" cy="749808"/>
           </a:xfrm>
           <a:prstGeom prst="rect">
             <a:avLst/>
@@ -3489,59 +3459,61 @@
           <a:p>
             <a:pPr>
               <a:spcAft>
-                <a:spcPts val="400"/>
-              </a:spcAft>
-              <a:defRPr sz="1400"/>
-            </a:pPr>
-            <a:r>
-              <a:t>In: pyleecan machine files (the real Toyota_Prius.json reads to exactly the model). Out: pyleecan JSON, FEMM Lua, Elmer case, gmsh/GetDP, MATLAB .mat, DXF, VTK, CSV/Parquet/HDF5 data contracts.</a:t>
-            </a:r>
-          </a:p>
-          <a:p>
-            <a:pPr>
-              <a:spcAft>
-                <a:spcPts val="400"/>
-              </a:spcAft>
-              <a:defRPr sz="1400"/>
-            </a:pPr>
-            <a:r>
-              <a:t>What is verified: closed forms (FEM, filaments, thermal, skew factor, drive), a second FEA code, a published torque curve.</a:t>
-            </a:r>
-          </a:p>
-          <a:p>
-            <a:pPr>
-              <a:spcAft>
-                <a:spcPts val="400"/>
-              </a:spcAft>
-              <a:defRPr sz="1400"/>
-            </a:pPr>
-            <a:r>
-              <a:t>Not verified: any measurement of this motor; FEMM/pyleecan/Elmer runs; cogging to better than about 25 %; thermal data; magnet grade.</a:t>
-            </a:r>
-          </a:p>
-          <a:p>
-            <a:pPr>
-              <a:spcAft>
-                <a:spcPts val="400"/>
-              </a:spcAft>
-              <a:defRPr sz="1400"/>
-            </a:pPr>
-            <a:r>
-              <a:t>Next: test-bench data (torque, EMF, temperatures) to calibrate thermal and loss models; a 3-D coupled end-region solution at load; bridge stress as a design constraint.</a:t>
-            </a:r>
-          </a:p>
-        </p:txBody>
-      </p:sp>
-      <p:sp>
-        <p:nvSpPr>
-          <p:cNvPr id="4" name="TextBox 3"/>
+                <a:spcPts val="500"/>
+              </a:spcAft>
+              <a:defRPr sz="1800" i="0" b="0"/>
+            </a:pPr>
+            <a:r>
+              <a:t>Equal quality: 51-53 FEA calls (hybrid, dots) vs 601-711 (NSGA-II on the FEA): 91-93 % fewer.</a:t>
+            </a:r>
+          </a:p>
+          <a:p>
+            <a:pPr>
+              <a:spcAft>
+                <a:spcPts val="500"/>
+              </a:spcAft>
+              <a:defRPr sz="1800" i="0" b="0"/>
+            </a:pPr>
+            <a:r>
+              <a:t>Front designs beating the Prius rotor sit at the 1.0 mm bridge bound (Prius 1.5 mm); 288 gap nodes.</a:t>
+            </a:r>
+          </a:p>
+        </p:txBody>
+      </p:sp>
+      <p:pic>
+        <p:nvPicPr>
+          <p:cNvPr id="4" name="Picture 3" descr="image.png"/>
+          <p:cNvPicPr>
+            <a:picLocks noChangeAspect="1"/>
+          </p:cNvPicPr>
+          <p:nvPr/>
+        </p:nvPicPr>
+        <p:blipFill>
+          <a:blip r:embed="rId2"/>
+          <a:stretch>
+            <a:fillRect/>
+          </a:stretch>
+        </p:blipFill>
+        <p:spPr>
+          <a:xfrm>
+            <a:off x="411480" y="1801368"/>
+            <a:ext cx="11369040" cy="4251836"/>
+          </a:xfrm>
+          <a:prstGeom prst="rect">
+            <a:avLst/>
+          </a:prstGeom>
+        </p:spPr>
+      </p:pic>
+      <p:sp>
+        <p:nvSpPr>
+          <p:cNvPr id="5" name="TextBox 4"/>
           <p:cNvSpPr txBox="1"/>
           <p:nvPr/>
         </p:nvSpPr>
         <p:spPr>
           <a:xfrm>
-            <a:off x="400000" y="6108000"/>
-            <a:ext cx="11392000" cy="600000"/>
+            <a:off x="411480" y="6309360"/>
+            <a:ext cx="11369040" cy="457200"/>
           </a:xfrm>
           <a:prstGeom prst="rect">
             <a:avLst/>
@@ -3555,7 +3527,171 @@
           <a:lstStyle/>
           <a:p>
             <a:pPr>
-              <a:defRPr sz="1100" i="1"/>
+              <a:spcAft>
+                <a:spcPts val="500"/>
+              </a:spcAft>
+              <a:defRPr sz="1300" i="1" b="0">
+                <a:solidFill>
+                  <a:srgbClr val="555555"/>
+                </a:solidFill>
+              </a:defRPr>
+            </a:pPr>
+            <a:r>
+              <a:t>Limits: no bridge stress, demagnetisation or speed constraints: the method and its saving, not a better rotor.</a:t>
+            </a:r>
+          </a:p>
+        </p:txBody>
+      </p:sp>
+    </p:spTree>
+  </p:cSld>
+  <p:clrMapOvr>
+    <a:masterClrMapping/>
+  </p:clrMapOvr>
+</p:sld>
+</file>
+
+<file path=ppt/slides/slide12.xml><?xml version="1.0" encoding="utf-8"?>
+<p:sld xmlns:a="http://schemas.openxmlformats.org/drawingml/2006/main" xmlns:p="http://schemas.openxmlformats.org/presentationml/2006/main" xmlns:r="http://schemas.openxmlformats.org/officeDocument/2006/relationships">
+  <p:cSld>
+    <p:spTree>
+      <p:nvGrpSpPr>
+        <p:cNvPr id="1" name=""/>
+        <p:cNvGrpSpPr/>
+        <p:nvPr/>
+      </p:nvGrpSpPr>
+      <p:grpSpPr/>
+      <p:sp>
+        <p:nvSpPr>
+          <p:cNvPr id="2" name="TextBox 1"/>
+          <p:cNvSpPr txBox="1"/>
+          <p:nvPr/>
+        </p:nvSpPr>
+        <p:spPr>
+          <a:xfrm>
+            <a:off x="411480" y="228600"/>
+            <a:ext cx="11369040" cy="640080"/>
+          </a:xfrm>
+          <a:prstGeom prst="rect">
+            <a:avLst/>
+          </a:prstGeom>
+          <a:noFill/>
+        </p:spPr>
+        <p:txBody>
+          <a:bodyPr wrap="square">
+            <a:spAutoFit/>
+          </a:bodyPr>
+          <a:lstStyle/>
+          <a:p>
+            <a:pPr>
+              <a:spcAft>
+                <a:spcPts val="500"/>
+              </a:spcAft>
+              <a:defRPr sz="2800" i="0" b="1"/>
+            </a:pPr>
+            <a:r>
+              <a:t>What is verified, what is not, what would close it</a:t>
+            </a:r>
+          </a:p>
+        </p:txBody>
+      </p:sp>
+      <p:sp>
+        <p:nvSpPr>
+          <p:cNvPr id="3" name="TextBox 2"/>
+          <p:cNvSpPr txBox="1"/>
+          <p:nvPr/>
+        </p:nvSpPr>
+        <p:spPr>
+          <a:xfrm>
+            <a:off x="411480" y="914400"/>
+            <a:ext cx="11369040" cy="2706624"/>
+          </a:xfrm>
+          <a:prstGeom prst="rect">
+            <a:avLst/>
+          </a:prstGeom>
+          <a:noFill/>
+        </p:spPr>
+        <p:txBody>
+          <a:bodyPr wrap="square">
+            <a:spAutoFit/>
+          </a:bodyPr>
+          <a:lstStyle/>
+          <a:p>
+            <a:pPr>
+              <a:spcAft>
+                <a:spcPts val="500"/>
+              </a:spcAft>
+              <a:defRPr sz="1800" i="0" b="0"/>
+            </a:pPr>
+            <a:r>
+              <a:t>Verified: closed forms (FEM, filament inductance, thermal network, skew factor, drive optimiser); a second FEA code (torque, EMF, inductances); a published torque curve.</a:t>
+            </a:r>
+          </a:p>
+          <a:p>
+            <a:pPr>
+              <a:spcAft>
+                <a:spcPts val="500"/>
+              </a:spcAft>
+              <a:defRPr sz="1800" i="0" b="0"/>
+            </a:pPr>
+            <a:r>
+              <a:t>Not verified: any measurement of this motor; cogging to better than ~25 %; thermal parameters; magnet grade; FEMM, pyleecan and Elmer runs (input files are written).</a:t>
+            </a:r>
+          </a:p>
+          <a:p>
+            <a:pPr>
+              <a:spcAft>
+                <a:spcPts val="500"/>
+              </a:spcAft>
+              <a:defRPr sz="1800" i="0" b="0"/>
+            </a:pPr>
+            <a:r>
+              <a:t>Test bench: locked-rotor torque vs current angle; no-load back-EMF and cogging; thermocouples in winding and end winding over a WLTC; standstill L_d, L_q; loss map.</a:t>
+            </a:r>
+          </a:p>
+          <a:p>
+            <a:pPr>
+              <a:spcAft>
+                <a:spcPts val="500"/>
+              </a:spcAft>
+              <a:defRPr sz="1800" i="0" b="0"/>
+            </a:pPr>
+            <a:r>
+              <a:t>Exchange: pyleecan in/out, FEMM Lua, Elmer, gmsh/GetDP, MATLAB, DXF, VTK, CSV/Parquet/HDF5 contracts.</a:t>
+            </a:r>
+          </a:p>
+        </p:txBody>
+      </p:sp>
+      <p:sp>
+        <p:nvSpPr>
+          <p:cNvPr id="4" name="TextBox 3"/>
+          <p:cNvSpPr txBox="1"/>
+          <p:nvPr/>
+        </p:nvSpPr>
+        <p:spPr>
+          <a:xfrm>
+            <a:off x="411480" y="6309360"/>
+            <a:ext cx="11369040" cy="457200"/>
+          </a:xfrm>
+          <a:prstGeom prst="rect">
+            <a:avLst/>
+          </a:prstGeom>
+          <a:noFill/>
+        </p:spPr>
+        <p:txBody>
+          <a:bodyPr wrap="square">
+            <a:spAutoFit/>
+          </a:bodyPr>
+          <a:lstStyle/>
+          <a:p>
+            <a:pPr>
+              <a:spcAft>
+                <a:spcPts val="500"/>
+              </a:spcAft>
+              <a:defRPr sz="1300" i="1" b="0">
+                <a:solidFill>
+                  <a:srgbClr val="555555"/>
+                </a:solidFill>
+              </a:defRPr>
             </a:pPr>
             <a:r>
               <a:t>Limits: see the Limits section of docs/guides/electromagnetics.md.</a:t>
@@ -3589,8 +3725,8 @@
         </p:nvSpPr>
         <p:spPr>
           <a:xfrm>
-            <a:off x="400000" y="250000"/>
-            <a:ext cx="11392000" cy="700000"/>
+            <a:off x="411480" y="228600"/>
+            <a:ext cx="11369040" cy="640080"/>
           </a:xfrm>
           <a:prstGeom prst="rect">
             <a:avLst/>
@@ -3598,14 +3734,19 @@
           <a:noFill/>
         </p:spPr>
         <p:txBody>
-          <a:bodyPr wrap="none">
+          <a:bodyPr wrap="square">
             <a:spAutoFit/>
           </a:bodyPr>
           <a:lstStyle/>
           <a:p>
-            <a:r>
-              <a:rPr sz="2600" b="1"/>
-              <a:t>2-D FEA, verified</a:t>
+            <a:pPr>
+              <a:spcAft>
+                <a:spcPts val="500"/>
+              </a:spcAft>
+              <a:defRPr sz="2800" i="0" b="1"/>
+            </a:pPr>
+            <a:r>
+              <a:t>Executive summary</a:t>
             </a:r>
           </a:p>
         </p:txBody>
@@ -3618,8 +3759,8 @@
         </p:nvSpPr>
         <p:spPr>
           <a:xfrm>
-            <a:off x="400000" y="1000000"/>
-            <a:ext cx="11392000" cy="1570000"/>
+            <a:off x="411480" y="914400"/>
+            <a:ext cx="11369040" cy="4736592"/>
           </a:xfrm>
           <a:prstGeom prst="rect">
             <a:avLst/>
@@ -3634,83 +3775,92 @@
           <a:p>
             <a:pPr>
               <a:spcAft>
-                <a:spcPts val="400"/>
-              </a:spcAft>
-              <a:defRPr sz="1400"/>
-            </a:pPr>
-            <a:r>
-              <a:t>Nonlinear A_z FEM, conforming mirrored meshes, Arkkio torque: 29936 elements.</a:t>
-            </a:r>
-          </a:p>
-          <a:p>
-            <a:pPr>
-              <a:spcAft>
-                <a:spcPts val="400"/>
-              </a:spcAft>
-              <a:defRPr sz="1400"/>
-            </a:pPr>
-            <a:r>
-              <a:t>Verification cases against closed forms: 6 of 6 pass (magnetised ring: second order, as P1 should).</a:t>
-            </a:r>
-          </a:p>
-          <a:p>
-            <a:pPr>
-              <a:spcAft>
-                <a:spcPts val="400"/>
-              </a:spcAft>
-              <a:defRPr sz="1400"/>
-            </a:pPr>
-            <a:r>
-              <a:t>Torque vs current angle at 250 A against Yang et al. 2013: peak 345.6 vs 353 N m, rms difference 13.3 N m (their model and the pyleecan geometry differ: centre post, steel data).</a:t>
-            </a:r>
-          </a:p>
-          <a:p>
-            <a:pPr>
-              <a:spcAft>
-                <a:spcPts val="400"/>
-              </a:spcAft>
-              <a:defRPr sz="1400"/>
-            </a:pPr>
-            <a:r>
-              <a:t>Cogging 1.38 N m pk-pk; back-EMF fundamental 87.6 V peak at 1000 rpm.</a:t>
-            </a:r>
-          </a:p>
-        </p:txBody>
-      </p:sp>
-      <p:pic>
-        <p:nvPicPr>
-          <p:cNvPr id="4" name="Picture 3" descr="10_pmsm_curves.png"/>
-          <p:cNvPicPr>
-            <a:picLocks noChangeAspect="1"/>
-          </p:cNvPicPr>
-          <p:nvPr/>
-        </p:nvPicPr>
-        <p:blipFill>
-          <a:blip r:embed="rId2"/>
-          <a:stretch>
-            <a:fillRect/>
-          </a:stretch>
-        </p:blipFill>
-        <p:spPr>
-          <a:xfrm>
-            <a:off x="400000" y="2670000"/>
-            <a:ext cx="11392000" cy="2392320"/>
-          </a:xfrm>
-          <a:prstGeom prst="rect">
-            <a:avLst/>
-          </a:prstGeom>
-        </p:spPr>
-      </p:pic>
-      <p:sp>
-        <p:nvSpPr>
-          <p:cNvPr id="5" name="TextBox 4"/>
+                <a:spcPts val="500"/>
+              </a:spcAft>
+              <a:defRPr sz="1800" i="0" b="0"/>
+            </a:pPr>
+            <a:r>
+              <a:t>Done: 2-D nonlinear FEA of the Prius motor, checked against closed forms, a second FEA code (GetDP) and a published torque curve; drive, end effects, thermal, demagnetisation, skew, tolerances, design.</a:t>
+            </a:r>
+          </a:p>
+          <a:p>
+            <a:pPr>
+              <a:spcAft>
+                <a:spcPts val="500"/>
+              </a:spcAft>
+              <a:defRPr sz="1800" i="0" b="0"/>
+            </a:pPr>
+            <a:r>
+              <a:t>Torque at 250 A (R1, MTPA): 345.6 N m. Peak of the angle sweep 345.6 vs published 353 N m (-2.1 %); second code within 1.1 N m.</a:t>
+            </a:r>
+          </a:p>
+          <a:p>
+            <a:pPr>
+              <a:spcAft>
+                <a:spcPts val="500"/>
+              </a:spcAft>
+              <a:defRPr sz="1800" i="0" b="0"/>
+            </a:pPr>
+            <a:r>
+              <a:t>WLTC 3b, illustrative car: 102.1 Wh/km battery-side (motor losses only).</a:t>
+            </a:r>
+          </a:p>
+          <a:p>
+            <a:pPr>
+              <a:spcAft>
+                <a:spcPts val="500"/>
+              </a:spcAft>
+              <a:defRPr sz="1800" i="0" b="0"/>
+            </a:pPr>
+            <a:r>
+              <a:t>End effects: torque -2.6 % (magnet end leakage), high-speed envelope -11 % at 3000 rpm (end windings).</a:t>
+            </a:r>
+          </a:p>
+          <a:p>
+            <a:pPr>
+              <a:spcAft>
+                <a:spcPts val="500"/>
+              </a:spcAft>
+              <a:defRPr sz="1800" i="0" b="0"/>
+            </a:pPr>
+            <a:r>
+              <a:t>Two-step skew: ripple 22.9 -&gt; 8.8 % for -2.0 % torque. FEA + GP + NSGA-II: 91-93 % fewer FEA calls at equal quality.</a:t>
+            </a:r>
+          </a:p>
+          <a:p>
+            <a:pPr>
+              <a:spcAft>
+                <a:spcPts val="500"/>
+              </a:spcAft>
+              <a:defRPr sz="1800" i="0" b="0"/>
+            </a:pPr>
+            <a:r>
+              <a:t>Not verified: no measurement of this motor; cogging uncertain to ~25 % (two codes); thermal data illustrative; magnet grade unknown.</a:t>
+            </a:r>
+          </a:p>
+          <a:p>
+            <a:pPr>
+              <a:spcAft>
+                <a:spcPts val="500"/>
+              </a:spcAft>
+              <a:defRPr sz="1800" i="0" b="0"/>
+            </a:pPr>
+            <a:r>
+              <a:t>Test-bench data that would close the gaps: torque vs current angle and back-EMF; cogging; winding and magnet temperatures over a cycle; standstill inductances; loss map.</a:t>
+            </a:r>
+          </a:p>
+        </p:txBody>
+      </p:sp>
+      <p:sp>
+        <p:nvSpPr>
+          <p:cNvPr id="4" name="TextBox 3"/>
           <p:cNvSpPr txBox="1"/>
           <p:nvPr/>
         </p:nvSpPr>
         <p:spPr>
           <a:xfrm>
-            <a:off x="400000" y="6108000"/>
-            <a:ext cx="11392000" cy="600000"/>
+            <a:off x="411480" y="6309360"/>
+            <a:ext cx="11369040" cy="457200"/>
           </a:xfrm>
           <a:prstGeom prst="rect">
             <a:avLst/>
@@ -3724,10 +3874,17 @@
           <a:lstStyle/>
           <a:p>
             <a:pPr>
-              <a:defRPr sz="1100" i="1"/>
-            </a:pPr>
-            <a:r>
-              <a:t>Limits: 2-D only; P1 elements; iron loss from B waveforms without minor loops.</a:t>
+              <a:spcAft>
+                <a:spcPts val="500"/>
+              </a:spcAft>
+              <a:defRPr sz="1300" i="1" b="0">
+                <a:solidFill>
+                  <a:srgbClr val="555555"/>
+                </a:solidFill>
+              </a:defRPr>
+            </a:pPr>
+            <a:r>
+              <a:t>Limits: a model study from public data (pyleecan geometry, M400-50A steel).</a:t>
             </a:r>
           </a:p>
         </p:txBody>
@@ -3758,8 +3915,8 @@
         </p:nvSpPr>
         <p:spPr>
           <a:xfrm>
-            <a:off x="400000" y="250000"/>
-            <a:ext cx="11392000" cy="700000"/>
+            <a:off x="411480" y="228600"/>
+            <a:ext cx="11369040" cy="640080"/>
           </a:xfrm>
           <a:prstGeom prst="rect">
             <a:avLst/>
@@ -3767,14 +3924,19 @@
           <a:noFill/>
         </p:spPr>
         <p:txBody>
-          <a:bodyPr wrap="none">
+          <a:bodyPr wrap="square">
             <a:spAutoFit/>
           </a:bodyPr>
           <a:lstStyle/>
           <a:p>
-            <a:r>
-              <a:rPr sz="2600" b="1"/>
-              <a:t>Second code: gmsh + GetDP</a:t>
+            <a:pPr>
+              <a:spcAft>
+                <a:spcPts val="500"/>
+              </a:spcAft>
+              <a:defRPr sz="2800" i="0" b="1"/>
+            </a:pPr>
+            <a:r>
+              <a:t>2-D FEA, verified</a:t>
             </a:r>
           </a:p>
         </p:txBody>
@@ -3787,8 +3949,8 @@
         </p:nvSpPr>
         <p:spPr>
           <a:xfrm>
-            <a:off x="400000" y="1000000"/>
-            <a:ext cx="11392000" cy="1240000"/>
+            <a:off x="411480" y="914400"/>
+            <a:ext cx="7147560" cy="1051560"/>
           </a:xfrm>
           <a:prstGeom prst="rect">
             <a:avLst/>
@@ -3803,41 +3965,30 @@
           <a:p>
             <a:pPr>
               <a:spcAft>
-                <a:spcPts val="400"/>
-              </a:spcAft>
-              <a:defRPr sz="1400"/>
-            </a:pPr>
-            <a:r>
-              <a:t>Same geometry and materials, GetDP's own mesh, Newton solver and torque: torque vs angle within 1.09 N m.</a:t>
-            </a:r>
-          </a:p>
-          <a:p>
-            <a:pPr>
-              <a:spcAft>
-                <a:spcPts val="400"/>
-              </a:spcAft>
-              <a:defRPr sz="1400"/>
-            </a:pPr>
-            <a:r>
-              <a:t>Back-EMF fundamental 87.60 vs 87.64 V; L_d 1.370 vs 1.385 mH; L_q 1.856 vs 1.864 mH.</a:t>
-            </a:r>
-          </a:p>
-          <a:p>
-            <a:pPr>
-              <a:spcAft>
-                <a:spcPts val="400"/>
-              </a:spcAft>
-              <a:defRPr sz="1400"/>
-            </a:pPr>
-            <a:r>
-              <a:t>Cogging does not agree: 1.34 vs 1.00 N m at 1920 gap nodes, both converged; with linear iron 1.223 vs 1.211 N m -&gt; the difference is in the saturated bridges.</a:t>
+                <a:spcPts val="500"/>
+              </a:spcAft>
+              <a:defRPr sz="1800" i="0" b="0"/>
+            </a:pPr>
+            <a:r>
+              <a:t>Torque vs current angle at 250 A against Yang et al. 2013: rms difference 13.3 N m.</a:t>
+            </a:r>
+          </a:p>
+          <a:p>
+            <a:pPr>
+              <a:spcAft>
+                <a:spcPts val="500"/>
+              </a:spcAft>
+              <a:defRPr sz="1800" i="0" b="0"/>
+            </a:pPr>
+            <a:r>
+              <a:t>Closed-form verification cases: 6 of 6 pass.</a:t>
             </a:r>
           </a:p>
         </p:txBody>
       </p:sp>
       <p:pic>
         <p:nvPicPr>
-          <p:cNvPr id="4" name="Picture 3" descr="14_prius_getdp_crosscheck.png"/>
+          <p:cNvPr id="4" name="Picture 3" descr="image.png"/>
           <p:cNvPicPr>
             <a:picLocks noChangeAspect="1"/>
           </p:cNvPicPr>
@@ -3851,8 +4002,8 @@
         </p:blipFill>
         <p:spPr>
           <a:xfrm>
-            <a:off x="400000" y="2340000"/>
-            <a:ext cx="11392000" cy="3061600"/>
+            <a:off x="411480" y="2103120"/>
+            <a:ext cx="6873903" cy="4160520"/>
           </a:xfrm>
           <a:prstGeom prst="rect">
             <a:avLst/>
@@ -3861,14 +4012,161 @@
       </p:pic>
       <p:sp>
         <p:nvSpPr>
-          <p:cNvPr id="5" name="TextBox 4"/>
+          <p:cNvPr id="5" name="Rectangle 4"/>
+          <p:cNvSpPr/>
+          <p:nvPr/>
+        </p:nvSpPr>
+        <p:spPr>
+          <a:xfrm>
+            <a:off x="7559040" y="914400"/>
+            <a:ext cx="4221480" cy="5212080"/>
+          </a:xfrm>
+          <a:prstGeom prst="rect">
+            <a:avLst/>
+          </a:prstGeom>
+          <a:solidFill>
+            <a:srgbClr val="EEF3F8"/>
+          </a:solidFill>
+          <a:ln>
+            <a:solidFill>
+              <a:srgbClr val="5B7DA8"/>
+            </a:solidFill>
+          </a:ln>
+        </p:spPr>
+        <p:style>
+          <a:lnRef idx="1">
+            <a:schemeClr val="accent1"/>
+          </a:lnRef>
+          <a:fillRef idx="3">
+            <a:schemeClr val="accent1"/>
+          </a:fillRef>
+          <a:effectRef idx="2">
+            <a:schemeClr val="accent1"/>
+          </a:effectRef>
+          <a:fontRef idx="minor">
+            <a:schemeClr val="lt1"/>
+          </a:fontRef>
+        </p:style>
+        <p:txBody>
+          <a:bodyPr rtlCol="0" anchor="ctr" wrap="square"/>
+          <a:lstStyle/>
+          <a:p>
+            <a:pPr algn="ctr">
+              <a:spcAft>
+                <a:spcPts val="600"/>
+              </a:spcAft>
+              <a:defRPr sz="1700" b="1">
+                <a:solidFill>
+                  <a:srgbClr val="1F2D3D"/>
+                </a:solidFill>
+              </a:defRPr>
+            </a:pPr>
+            <a:r>
+              <a:t>Reference values (R)</a:t>
+            </a:r>
+          </a:p>
+          <a:p>
+            <a:pPr>
+              <a:spcAft>
+                <a:spcPts val="600"/>
+              </a:spcAft>
+              <a:defRPr sz="1500" b="0">
+                <a:solidFill>
+                  <a:srgbClr val="1F2D3D"/>
+                </a:solidFill>
+              </a:defRPr>
+            </a:pPr>
+            <a:r>
+              <a:t>Mesh: 960 gap nodes, 29936 elements; magnets 20 degC</a:t>
+            </a:r>
+          </a:p>
+          <a:p>
+            <a:pPr>
+              <a:spcAft>
+                <a:spcPts val="600"/>
+              </a:spcAft>
+              <a:defRPr sz="1500" b="0">
+                <a:solidFill>
+                  <a:srgbClr val="1F2D3D"/>
+                </a:solidFill>
+              </a:defRPr>
+            </a:pPr>
+            <a:r>
+              <a:t>R1  torque at 250 A, MTPA (50.3 deg), 12 rotor angles: 345.6 N m</a:t>
+            </a:r>
+          </a:p>
+          <a:p>
+            <a:pPr>
+              <a:spcAft>
+                <a:spcPts val="600"/>
+              </a:spcAft>
+              <a:defRPr sz="1500" b="0">
+                <a:solidFill>
+                  <a:srgbClr val="1F2D3D"/>
+                </a:solidFill>
+              </a:defRPr>
+            </a:pPr>
+            <a:r>
+              <a:t>R2  cogging pk-pk, 24 angles per slot pitch: 1.38 N m</a:t>
+            </a:r>
+          </a:p>
+          <a:p>
+            <a:pPr>
+              <a:spcAft>
+                <a:spcPts val="600"/>
+              </a:spcAft>
+              <a:defRPr sz="1500" b="0">
+                <a:solidFill>
+                  <a:srgbClr val="1F2D3D"/>
+                </a:solidFill>
+              </a:defRPr>
+            </a:pPr>
+            <a:r>
+              <a:t>R3  back-EMF fundamental, 1000 rpm: 87.6 V peak, THD 9.3 %</a:t>
+            </a:r>
+          </a:p>
+          <a:p>
+            <a:pPr>
+              <a:spcAft>
+                <a:spcPts val="600"/>
+              </a:spcAft>
+              <a:defRPr sz="1500" b="0">
+                <a:solidFill>
+                  <a:srgbClr val="1F2D3D"/>
+                </a:solidFill>
+              </a:defRPr>
+            </a:pPr>
+            <a:r>
+              <a:t>R4  L_d / L_q at R1: 1.386 / 2.435 mH</a:t>
+            </a:r>
+          </a:p>
+          <a:p>
+            <a:pPr>
+              <a:spcAft>
+                <a:spcPts val="600"/>
+              </a:spcAft>
+              <a:defRPr sz="1500" b="0">
+                <a:solidFill>
+                  <a:srgbClr val="1F2D3D"/>
+                </a:solidFill>
+              </a:defRPr>
+            </a:pPr>
+            <a:r>
+              <a:t>Other slides give their mesh or definition where it differs.</a:t>
+            </a:r>
+          </a:p>
+        </p:txBody>
+      </p:sp>
+      <p:sp>
+        <p:nvSpPr>
+          <p:cNvPr id="6" name="TextBox 5"/>
           <p:cNvSpPr txBox="1"/>
           <p:nvPr/>
         </p:nvSpPr>
         <p:spPr>
           <a:xfrm>
-            <a:off x="400000" y="6108000"/>
-            <a:ext cx="11392000" cy="600000"/>
+            <a:off x="411480" y="6309360"/>
+            <a:ext cx="11369040" cy="457200"/>
           </a:xfrm>
           <a:prstGeom prst="rect">
             <a:avLst/>
@@ -3882,10 +4180,17 @@
           <a:lstStyle/>
           <a:p>
             <a:pPr>
-              <a:defRPr sz="1100" i="1"/>
-            </a:pPr>
-            <a:r>
-              <a:t>Limits: cogging uncertain by about 25 % between two codes; FEMM, pyleecan, Elmer not run (inputs written).</a:t>
+              <a:spcAft>
+                <a:spcPts val="500"/>
+              </a:spcAft>
+              <a:defRPr sz="1300" i="1" b="0">
+                <a:solidFill>
+                  <a:srgbClr val="555555"/>
+                </a:solidFill>
+              </a:defRPr>
+            </a:pPr>
+            <a:r>
+              <a:t>Limits: 2-D; P1 elements; the published model and the pyleecan geometry differ (centre post, steel data).</a:t>
             </a:r>
           </a:p>
         </p:txBody>
@@ -3916,8 +4221,8 @@
         </p:nvSpPr>
         <p:spPr>
           <a:xfrm>
-            <a:off x="400000" y="250000"/>
-            <a:ext cx="11392000" cy="700000"/>
+            <a:off x="411480" y="228600"/>
+            <a:ext cx="11369040" cy="640080"/>
           </a:xfrm>
           <a:prstGeom prst="rect">
             <a:avLst/>
@@ -3925,14 +4230,19 @@
           <a:noFill/>
         </p:spPr>
         <p:txBody>
-          <a:bodyPr wrap="none">
+          <a:bodyPr wrap="square">
             <a:spAutoFit/>
           </a:bodyPr>
           <a:lstStyle/>
           <a:p>
-            <a:r>
-              <a:rPr sz="2600" b="1"/>
-              <a:t>Drive: MTPA, flux weakening, WLTC</a:t>
+            <a:pPr>
+              <a:spcAft>
+                <a:spcPts val="500"/>
+              </a:spcAft>
+              <a:defRPr sz="2800" i="0" b="1"/>
+            </a:pPr>
+            <a:r>
+              <a:t>Second code: gmsh + GetDP</a:t>
             </a:r>
           </a:p>
         </p:txBody>
@@ -3945,8 +4255,8 @@
         </p:nvSpPr>
         <p:spPr>
           <a:xfrm>
-            <a:off x="400000" y="1000000"/>
-            <a:ext cx="11392000" cy="1570000"/>
+            <a:off x="411480" y="914400"/>
+            <a:ext cx="11369040" cy="1051560"/>
           </a:xfrm>
           <a:prstGeom prst="rect">
             <a:avLst/>
@@ -3961,52 +4271,30 @@
           <a:p>
             <a:pPr>
               <a:spcAft>
-                <a:spcPts val="400"/>
-              </a:spcAft>
-              <a:defRPr sz="1400"/>
-            </a:pPr>
-            <a:r>
-              <a:t>FEA flux map (saturation, cross-saturation), 250 A, 500 V DC with SVPWM: 343.6 N m at low speed, 104.4 N m at 6000 rpm, 77.7 kW peak.</a:t>
-            </a:r>
-          </a:p>
-          <a:p>
-            <a:pPr>
-              <a:spcAft>
-                <a:spcPts val="400"/>
-              </a:spcAft>
-              <a:defRPr sz="1400"/>
-            </a:pPr>
-            <a:r>
-              <a:t>Peak efficiency 96.2 % at 2750 rpm, 70.7 N m (copper + iron + magnet loss).</a:t>
-            </a:r>
-          </a:p>
-          <a:p>
-            <a:pPr>
-              <a:spcAft>
-                <a:spcPts val="400"/>
-              </a:spcAft>
-              <a:defRPr sz="1400"/>
-            </a:pPr>
-            <a:r>
-              <a:t>WLTC class 3b, illustrative compact car: 102.1 Wh/km at the battery (drive losses only).</a:t>
-            </a:r>
-          </a:p>
-          <a:p>
-            <a:pPr>
-              <a:spcAft>
-                <a:spcPts val="400"/>
-              </a:spcAft>
-              <a:defRPr sz="1400"/>
-            </a:pPr>
-            <a:r>
-              <a:t>Optimiser checked against the closed forms of a linear machine (1e-14) and energy bookkeeping.</a:t>
+                <a:spcPts val="500"/>
+              </a:spcAft>
+              <a:defRPr sz="1800" i="0" b="0"/>
+            </a:pPr>
+            <a:r>
+              <a:t>Torque vs angle: within 1.09 N m (960 nodes, as R1); EMF 87.60 vs 87.64 V (R3).</a:t>
+            </a:r>
+          </a:p>
+          <a:p>
+            <a:pPr>
+              <a:spcAft>
+                <a:spcPts val="500"/>
+              </a:spcAft>
+              <a:defRPr sz="1800" i="0" b="0"/>
+            </a:pPr>
+            <a:r>
+              <a:t>Cogging, 12 angles per slot pitch: 1.34 vs 1.00 N m at 1920 nodes; linear iron agrees (1.22 vs 1.21): the gap is in the saturated bridges.</a:t>
             </a:r>
           </a:p>
         </p:txBody>
       </p:sp>
       <p:pic>
         <p:nvPicPr>
-          <p:cNvPr id="4" name="Picture 3" descr="11_prius_drive.png"/>
+          <p:cNvPr id="4" name="Picture 3" descr="image.png"/>
           <p:cNvPicPr>
             <a:picLocks noChangeAspect="1"/>
           </p:cNvPicPr>
@@ -4020,8 +4308,8 @@
         </p:blipFill>
         <p:spPr>
           <a:xfrm>
-            <a:off x="1861000" y="2670000"/>
-            <a:ext cx="8470000" cy="3388000"/>
+            <a:off x="533565" y="2103120"/>
+            <a:ext cx="11124869" cy="4160520"/>
           </a:xfrm>
           <a:prstGeom prst="rect">
             <a:avLst/>
@@ -4036,8 +4324,8 @@
         </p:nvSpPr>
         <p:spPr>
           <a:xfrm>
-            <a:off x="400000" y="6108000"/>
-            <a:ext cx="11392000" cy="600000"/>
+            <a:off x="411480" y="6309360"/>
+            <a:ext cx="11369040" cy="457200"/>
           </a:xfrm>
           <a:prstGeom prst="rect">
             <a:avLst/>
@@ -4051,10 +4339,17 @@
           <a:lstStyle/>
           <a:p>
             <a:pPr>
-              <a:defRPr sz="1100" i="1"/>
-            </a:pPr>
-            <a:r>
-              <a:t>Limits: steady state; no inverter, mechanical or battery losses; the car is not a measured Prius.</a:t>
+              <a:spcAft>
+                <a:spcPts val="500"/>
+              </a:spcAft>
+              <a:defRPr sz="1300" i="1" b="0">
+                <a:solidFill>
+                  <a:srgbClr val="555555"/>
+                </a:solidFill>
+              </a:defRPr>
+            </a:pPr>
+            <a:r>
+              <a:t>Limits: cogging uncertain by ~25 % between the codes; FEMM, pyleecan, Elmer not run.</a:t>
             </a:r>
           </a:p>
         </p:txBody>
@@ -4085,8 +4380,8 @@
         </p:nvSpPr>
         <p:spPr>
           <a:xfrm>
-            <a:off x="400000" y="250000"/>
-            <a:ext cx="11392000" cy="700000"/>
+            <a:off x="411480" y="228600"/>
+            <a:ext cx="11369040" cy="640080"/>
           </a:xfrm>
           <a:prstGeom prst="rect">
             <a:avLst/>
@@ -4094,14 +4389,19 @@
           <a:noFill/>
         </p:spPr>
         <p:txBody>
-          <a:bodyPr wrap="none">
+          <a:bodyPr wrap="square">
             <a:spAutoFit/>
           </a:bodyPr>
           <a:lstStyle/>
           <a:p>
-            <a:r>
-              <a:rPr sz="2600" b="1"/>
-              <a:t>End effects</a:t>
+            <a:pPr>
+              <a:spcAft>
+                <a:spcPts val="500"/>
+              </a:spcAft>
+              <a:defRPr sz="2800" i="0" b="1"/>
+            </a:pPr>
+            <a:r>
+              <a:t>Drive: MTPA, flux weakening, efficiency</a:t>
             </a:r>
           </a:p>
         </p:txBody>
@@ -4114,8 +4414,8 @@
         </p:nvSpPr>
         <p:spPr>
           <a:xfrm>
-            <a:off x="400000" y="1000000"/>
-            <a:ext cx="11392000" cy="1570000"/>
+            <a:off x="411480" y="914400"/>
+            <a:ext cx="11369040" cy="1051560"/>
           </a:xfrm>
           <a:prstGeom prst="rect">
             <a:avLst/>
@@ -4130,52 +4430,30 @@
           <a:p>
             <a:pPr>
               <a:spcAft>
-                <a:spcPts val="400"/>
-              </a:spcAft>
-              <a:defRPr sz="1400"/>
-            </a:pPr>
-            <a:r>
-              <a:t>End windings (Neumann, thin filaments, verified against Rosa and Maxwell): L_end 135.2 uH in air, 115.3 uH with the iron face.</a:t>
-            </a:r>
-          </a:p>
-          <a:p>
-            <a:pPr>
-              <a:spcAft>
-                <a:spcPts val="400"/>
-              </a:spcAft>
-              <a:defRPr sz="1400"/>
-            </a:pPr>
-            <a:r>
-              <a:t>Effect on the envelope at 3000 rpm: 239.3 -&gt; 213.3 N m.</a:t>
-            </a:r>
-          </a:p>
-          <a:p>
-            <a:pPr>
-              <a:spcAft>
-                <a:spcPts val="400"/>
-              </a:spcAft>
-              <a:defRPr sz="1400"/>
-            </a:pPr>
-            <a:r>
-              <a:t>Magnet end leakage, 3-D GetDP model of half the stack: flux ratio 0.9345 -&gt; 0.9463 -&gt; 0.9482 on three meshes.</a:t>
-            </a:r>
-          </a:p>
-          <a:p>
-            <a:pPr>
-              <a:spcAft>
-                <a:spcPts val="400"/>
-              </a:spcAft>
-              <a:defRPr sz="1400"/>
-            </a:pPr>
-            <a:r>
-              <a:t>Corrected 2-D model: MTPA torque -2.6 %, back-EMF -5.4 %.</a:t>
+                <a:spcPts val="500"/>
+              </a:spcAft>
+              <a:defRPr sz="1800" i="0" b="0"/>
+            </a:pPr>
+            <a:r>
+              <a:t>250 A, 500 V DC (SVPWM), FEA flux map (480 gap nodes, interpolated): 343.6 N m at low speed, 77.7 kW peak.</a:t>
+            </a:r>
+          </a:p>
+          <a:p>
+            <a:pPr>
+              <a:spcAft>
+                <a:spcPts val="500"/>
+              </a:spcAft>
+              <a:defRPr sz="1800" i="0" b="0"/>
+            </a:pPr>
+            <a:r>
+              <a:t>Peak efficiency 96.2 % at 2750 rpm; WLTC 3b 102.1 Wh/km (illustrative car).</a:t>
             </a:r>
           </a:p>
         </p:txBody>
       </p:sp>
       <p:pic>
         <p:nvPicPr>
-          <p:cNvPr id="4" name="Picture 3" descr="16_prius_end_effects.png"/>
+          <p:cNvPr id="4" name="Picture 3" descr="image.png"/>
           <p:cNvPicPr>
             <a:picLocks noChangeAspect="1"/>
           </p:cNvPicPr>
@@ -4189,8 +4467,8 @@
         </p:blipFill>
         <p:spPr>
           <a:xfrm>
-            <a:off x="400000" y="2670000"/>
-            <a:ext cx="11392000" cy="3061600"/>
+            <a:off x="2025926" y="2103120"/>
+            <a:ext cx="8140148" cy="4160520"/>
           </a:xfrm>
           <a:prstGeom prst="rect">
             <a:avLst/>
@@ -4205,8 +4483,8 @@
         </p:nvSpPr>
         <p:spPr>
           <a:xfrm>
-            <a:off x="400000" y="6108000"/>
-            <a:ext cx="11392000" cy="600000"/>
+            <a:off x="411480" y="6309360"/>
+            <a:ext cx="11369040" cy="457200"/>
           </a:xfrm>
           <a:prstGeom prst="rect">
             <a:avLst/>
@@ -4220,10 +4498,17 @@
           <a:lstStyle/>
           <a:p>
             <a:pPr>
-              <a:defRPr sz="1100" i="1"/>
-            </a:pPr>
-            <a:r>
-              <a:t>Limits: corrections, not a coupled 3-D solution at load; no measured end-winding inductance to compare.</a:t>
+              <a:spcAft>
+                <a:spcPts val="500"/>
+              </a:spcAft>
+              <a:defRPr sz="1300" i="1" b="0">
+                <a:solidFill>
+                  <a:srgbClr val="555555"/>
+                </a:solidFill>
+              </a:defRPr>
+            </a:pPr>
+            <a:r>
+              <a:t>Limits: steady state; no inverter, mechanical or battery losses; the car is not a Prius.</a:t>
             </a:r>
           </a:p>
         </p:txBody>
@@ -4254,8 +4539,8 @@
         </p:nvSpPr>
         <p:spPr>
           <a:xfrm>
-            <a:off x="400000" y="250000"/>
-            <a:ext cx="11392000" cy="700000"/>
+            <a:off x="411480" y="228600"/>
+            <a:ext cx="11369040" cy="640080"/>
           </a:xfrm>
           <a:prstGeom prst="rect">
             <a:avLst/>
@@ -4263,14 +4548,19 @@
           <a:noFill/>
         </p:spPr>
         <p:txBody>
-          <a:bodyPr wrap="none">
+          <a:bodyPr wrap="square">
             <a:spAutoFit/>
           </a:bodyPr>
           <a:lstStyle/>
           <a:p>
-            <a:r>
-              <a:rPr sz="2600" b="1"/>
-              <a:t>Magnet temperature and thermal network</a:t>
+            <a:pPr>
+              <a:spcAft>
+                <a:spcPts val="500"/>
+              </a:spcAft>
+              <a:defRPr sz="2800" i="0" b="1"/>
+            </a:pPr>
+            <a:r>
+              <a:t>End effects</a:t>
             </a:r>
           </a:p>
         </p:txBody>
@@ -4283,8 +4573,8 @@
         </p:nvSpPr>
         <p:spPr>
           <a:xfrm>
-            <a:off x="400000" y="1000000"/>
-            <a:ext cx="11392000" cy="1240000"/>
+            <a:off x="411480" y="914400"/>
+            <a:ext cx="11369040" cy="749808"/>
           </a:xfrm>
           <a:prstGeom prst="rect">
             <a:avLst/>
@@ -4299,41 +4589,30 @@
           <a:p>
             <a:pPr>
               <a:spcAft>
-                <a:spcPts val="400"/>
-              </a:spcAft>
-              <a:defRPr sz="1400"/>
-            </a:pPr>
-            <a:r>
-              <a:t>Magnets 20 -&gt; 150 degC (Br -0.1 %/K): torque at 250 A 345.6 -&gt; 322.6 N m, back-EMF 87.6 -&gt; 75.4 V.</a:t>
-            </a:r>
-          </a:p>
-          <a:p>
-            <a:pPr>
-              <a:spcAft>
-                <a:spcPts val="400"/>
-              </a:spcAft>
-              <a:defRPr sz="1400"/>
-            </a:pPr>
-            <a:r>
-              <a:t>4 x WLTC from the drive losses: teeth 82.5, winding 80.3, magnets 78.5 degC.</a:t>
-            </a:r>
-          </a:p>
-          <a:p>
-            <a:pPr>
-              <a:spcAft>
-                <a:spcPts val="400"/>
-              </a:spcAft>
-              <a:defRPr sz="1400"/>
-            </a:pPr>
-            <a:r>
-              <a:t>Peak load from that state: hotter winding node at 180 degC after 237 s; magnets settle at 127 degC.</a:t>
+                <a:spcPts val="500"/>
+              </a:spcAft>
+              <a:defRPr sz="1800" i="0" b="0"/>
+            </a:pPr>
+            <a:r>
+              <a:t>End windings: L_end 135 uH (air) / 115 uH (iron face); envelope at 3000 rpm 239.3 -&gt; 213.3 N m.</a:t>
+            </a:r>
+          </a:p>
+          <a:p>
+            <a:pPr>
+              <a:spcAft>
+                <a:spcPts val="500"/>
+              </a:spcAft>
+              <a:defRPr sz="1800" i="0" b="0"/>
+            </a:pPr>
+            <a:r>
+              <a:t>Magnet end leakage (3-D GetDP, 3 meshes): flux x0.948; R1 345.7 -&gt; 336.7 N m, R3 87.6 -&gt; 82.9 V.</a:t>
             </a:r>
           </a:p>
         </p:txBody>
       </p:sp>
       <p:pic>
         <p:nvPicPr>
-          <p:cNvPr id="4" name="Picture 3" descr="13_prius_thermal.png"/>
+          <p:cNvPr id="4" name="Picture 3" descr="image.png"/>
           <p:cNvPicPr>
             <a:picLocks noChangeAspect="1"/>
           </p:cNvPicPr>
@@ -4347,8 +4626,8 @@
         </p:blipFill>
         <p:spPr>
           <a:xfrm>
-            <a:off x="400000" y="2340000"/>
-            <a:ext cx="11392000" cy="2881506"/>
+            <a:off x="411480" y="1801368"/>
+            <a:ext cx="11369040" cy="4251836"/>
           </a:xfrm>
           <a:prstGeom prst="rect">
             <a:avLst/>
@@ -4363,8 +4642,8 @@
         </p:nvSpPr>
         <p:spPr>
           <a:xfrm>
-            <a:off x="400000" y="6108000"/>
-            <a:ext cx="11392000" cy="600000"/>
+            <a:off x="411480" y="6309360"/>
+            <a:ext cx="11369040" cy="457200"/>
           </a:xfrm>
           <a:prstGeom prst="rect">
             <a:avLst/>
@@ -4378,10 +4657,17 @@
           <a:lstStyle/>
           <a:p>
             <a:pPr>
-              <a:defRPr sz="1100" i="1"/>
-            </a:pPr>
-            <a:r>
-              <a:t>Limits: seven-node network with illustrative thermal data (not fitted to a Prius); one temperature per node.</a:t>
+              <a:spcAft>
+                <a:spcPts val="500"/>
+              </a:spcAft>
+              <a:defRPr sz="1300" i="1" b="0">
+                <a:solidFill>
+                  <a:srgbClr val="555555"/>
+                </a:solidFill>
+              </a:defRPr>
+            </a:pPr>
+            <a:r>
+              <a:t>Limits: corrections, not a coupled 3-D solution at load; no measured end-winding inductance.</a:t>
             </a:r>
           </a:p>
         </p:txBody>
@@ -4412,8 +4698,8 @@
         </p:nvSpPr>
         <p:spPr>
           <a:xfrm>
-            <a:off x="400000" y="250000"/>
-            <a:ext cx="11392000" cy="700000"/>
+            <a:off x="411480" y="228600"/>
+            <a:ext cx="11369040" cy="640080"/>
           </a:xfrm>
           <a:prstGeom prst="rect">
             <a:avLst/>
@@ -4421,14 +4707,19 @@
           <a:noFill/>
         </p:spPr>
         <p:txBody>
-          <a:bodyPr wrap="none">
+          <a:bodyPr wrap="square">
             <a:spAutoFit/>
           </a:bodyPr>
           <a:lstStyle/>
           <a:p>
-            <a:r>
-              <a:rPr sz="2600" b="1"/>
-              <a:t>Demagnetisation</a:t>
+            <a:pPr>
+              <a:spcAft>
+                <a:spcPts val="500"/>
+              </a:spcAft>
+              <a:defRPr sz="2800" i="0" b="1"/>
+            </a:pPr>
+            <a:r>
+              <a:t>Magnet temperature and thermal network</a:t>
             </a:r>
           </a:p>
         </p:txBody>
@@ -4441,8 +4732,8 @@
         </p:nvSpPr>
         <p:spPr>
           <a:xfrm>
-            <a:off x="400000" y="1000000"/>
-            <a:ext cx="4986399" cy="4958000"/>
+            <a:off x="411480" y="914400"/>
+            <a:ext cx="11369040" cy="1051560"/>
           </a:xfrm>
           <a:prstGeom prst="rect">
             <a:avLst/>
@@ -4457,52 +4748,30 @@
           <a:p>
             <a:pPr>
               <a:spcAft>
-                <a:spcPts val="400"/>
-              </a:spcAft>
-              <a:defRPr sz="1400"/>
-            </a:pPr>
-            <a:r>
-              <a:t>Reverse field per magnet element against Hcj(T) of the grade letters, magnets at 127 degC.</a:t>
-            </a:r>
-          </a:p>
-          <a:p>
-            <a:pPr>
-              <a:spcAft>
-                <a:spcPts val="400"/>
-              </a:spcAft>
-              <a:defRPr sz="1400"/>
-            </a:pPr>
-            <a:r>
-              <a:t>Full d-axis current (-250 A): demagnetised area N 99.4 %, M 93.3 %, H 18.6 %, SH 2.4 %, UH 0.0 %.</a:t>
-            </a:r>
-          </a:p>
-          <a:p>
-            <a:pPr>
-              <a:spcAft>
-                <a:spcPts val="400"/>
-              </a:spcAft>
-              <a:defRPr sz="1400"/>
-            </a:pPr>
-            <a:r>
-              <a:t>Short-circuit estimate: N 31.8 %, M 3.2 %, H 0.0 %, SH 0.0 %, UH 0.0 %.</a:t>
-            </a:r>
-          </a:p>
-          <a:p>
-            <a:pPr>
-              <a:spcAft>
-                <a:spcPts val="400"/>
-              </a:spcAft>
-              <a:defRPr sz="1400"/>
-            </a:pPr>
-            <a:r>
-              <a:t>Mesh study inside the magnets (4 levels): grade H at -250 A 18.6 to 19.4 % -&gt; area fractions converge; the worst element does not (sharp corners).</a:t>
+                <a:spcPts val="500"/>
+              </a:spcAft>
+              <a:defRPr sz="1800" i="0" b="0"/>
+            </a:pPr>
+            <a:r>
+              <a:t>Magnets 20 -&gt; 150 degC: R1 345.6 -&gt; 322.6 N m, R3 87.6 -&gt; 75.4 V.</a:t>
+            </a:r>
+          </a:p>
+          <a:p>
+            <a:pPr>
+              <a:spcAft>
+                <a:spcPts val="500"/>
+              </a:spcAft>
+              <a:defRPr sz="1800" i="0" b="0"/>
+            </a:pPr>
+            <a:r>
+              <a:t>Peak load (343 N m, 1500 rpm) after 4 cycles: winding at 180 degC in 237 s; magnets settle at 127 degC.</a:t>
             </a:r>
           </a:p>
         </p:txBody>
       </p:sp>
       <p:pic>
         <p:nvPicPr>
-          <p:cNvPr id="4" name="Picture 3" descr="13_prius_demag.png"/>
+          <p:cNvPr id="4" name="Picture 3" descr="image.png"/>
           <p:cNvPicPr>
             <a:picLocks noChangeAspect="1"/>
           </p:cNvPicPr>
@@ -4516,8 +4785,8 @@
         </p:blipFill>
         <p:spPr>
           <a:xfrm>
-            <a:off x="5286399" y="1000000"/>
-            <a:ext cx="6069600" cy="5058000"/>
+            <a:off x="533565" y="2103120"/>
+            <a:ext cx="11124869" cy="4160520"/>
           </a:xfrm>
           <a:prstGeom prst="rect">
             <a:avLst/>
@@ -4532,8 +4801,8 @@
         </p:nvSpPr>
         <p:spPr>
           <a:xfrm>
-            <a:off x="400000" y="6108000"/>
-            <a:ext cx="11392000" cy="600000"/>
+            <a:off x="411480" y="6309360"/>
+            <a:ext cx="11369040" cy="457200"/>
           </a:xfrm>
           <a:prstGeom prst="rect">
             <a:avLst/>
@@ -4547,10 +4816,17 @@
           <a:lstStyle/>
           <a:p>
             <a:pPr>
-              <a:defRPr sz="1100" i="1"/>
-            </a:pPr>
-            <a:r>
-              <a:t>Limits: Hcj coefficient assumed (-0.55 %/K); static knee test; the Prius magnet grade was not found in accessible public sources, so the rows compare candidate grades.</a:t>
+              <a:spcAft>
+                <a:spcPts val="500"/>
+              </a:spcAft>
+              <a:defRPr sz="1300" i="1" b="0">
+                <a:solidFill>
+                  <a:srgbClr val="555555"/>
+                </a:solidFill>
+              </a:defRPr>
+            </a:pPr>
+            <a:r>
+              <a:t>Limits: seven-node network, illustrative thermal data (not fitted to a Prius).</a:t>
             </a:r>
           </a:p>
         </p:txBody>
@@ -4581,8 +4857,8 @@
         </p:nvSpPr>
         <p:spPr>
           <a:xfrm>
-            <a:off x="400000" y="250000"/>
-            <a:ext cx="11392000" cy="700000"/>
+            <a:off x="411480" y="228600"/>
+            <a:ext cx="11369040" cy="640080"/>
           </a:xfrm>
           <a:prstGeom prst="rect">
             <a:avLst/>
@@ -4590,14 +4866,19 @@
           <a:noFill/>
         </p:spPr>
         <p:txBody>
-          <a:bodyPr wrap="none">
+          <a:bodyPr wrap="square">
             <a:spAutoFit/>
           </a:bodyPr>
           <a:lstStyle/>
           <a:p>
-            <a:r>
-              <a:rPr sz="2600" b="1"/>
-              <a:t>Step skew</a:t>
+            <a:pPr>
+              <a:spcAft>
+                <a:spcPts val="500"/>
+              </a:spcAft>
+              <a:defRPr sz="2800" i="0" b="1"/>
+            </a:pPr>
+            <a:r>
+              <a:t>Demagnetisation at the hottest magnet temperature</a:t>
             </a:r>
           </a:p>
         </p:txBody>
@@ -4610,8 +4891,8 @@
         </p:nvSpPr>
         <p:spPr>
           <a:xfrm>
-            <a:off x="400000" y="1000000"/>
-            <a:ext cx="11392000" cy="1570000"/>
+            <a:off x="411480" y="914400"/>
+            <a:ext cx="11369040" cy="749808"/>
           </a:xfrm>
           <a:prstGeom prst="rect">
             <a:avLst/>
@@ -4626,52 +4907,30 @@
           <a:p>
             <a:pPr>
               <a:spcAft>
-                <a:spcPts val="400"/>
-              </a:spcAft>
-              <a:defRPr sz="1400"/>
-            </a:pPr>
-            <a:r>
-              <a:t>Multi-slice FEA. Straight rotor: cogging 1.35 N m, ripple 22.9 %, torque 345.6 N m.</a:t>
-            </a:r>
-          </a:p>
-          <a:p>
-            <a:pPr>
-              <a:spcAft>
-                <a:spcPts val="400"/>
-              </a:spcAft>
-              <a:defRPr sz="1400"/>
-            </a:pPr>
-            <a:r>
-              <a:t>2 steps over 3.75 deg: cogging 0.62 N m, ripple 8.8 %, torque 338.8 N m.</a:t>
-            </a:r>
-          </a:p>
-          <a:p>
-            <a:pPr>
-              <a:spcAft>
-                <a:spcPts val="400"/>
-              </a:spcAft>
-              <a:defRPr sz="1400"/>
-            </a:pPr>
-            <a:r>
-              <a:t>3 steps over 5.625 deg: cogging 0.42 N m, ripple 7.9 %, torque 335.3 N m.</a:t>
-            </a:r>
-          </a:p>
-          <a:p>
-            <a:pPr>
-              <a:spcAft>
-                <a:spcPts val="400"/>
-              </a:spcAft>
-              <a:defRPr sz="1400"/>
-            </a:pPr>
-            <a:r>
-              <a:t>Back-EMF fundamental x0.96593 vs closed-form skew factor 0.96593; THD 9.3 -&gt; 7.2 %.</a:t>
+                <a:spcPts val="500"/>
+              </a:spcAft>
+              <a:defRPr sz="1800" i="0" b="0"/>
+            </a:pPr>
+            <a:r>
+              <a:t>Magnets at 127 degC, reverse field per element against Hcj(T) of each grade letter.</a:t>
+            </a:r>
+          </a:p>
+          <a:p>
+            <a:pPr>
+              <a:spcAft>
+                <a:spcPts val="500"/>
+              </a:spcAft>
+              <a:defRPr sz="1800" i="0" b="0"/>
+            </a:pPr>
+            <a:r>
+              <a:t>Grade H loses 19 % of the magnet area at -250 A, SH 2.4 %; area fractions are mesh-converged.</a:t>
             </a:r>
           </a:p>
         </p:txBody>
       </p:sp>
       <p:pic>
         <p:nvPicPr>
-          <p:cNvPr id="4" name="Picture 3" descr="15_prius_skew.png"/>
+          <p:cNvPr id="4" name="Picture 3" descr="image.png"/>
           <p:cNvPicPr>
             <a:picLocks noChangeAspect="1"/>
           </p:cNvPicPr>
@@ -4685,8 +4944,8 @@
         </p:blipFill>
         <p:spPr>
           <a:xfrm>
-            <a:off x="400000" y="2670000"/>
-            <a:ext cx="11392000" cy="3061600"/>
+            <a:off x="411480" y="1801368"/>
+            <a:ext cx="11369040" cy="4251836"/>
           </a:xfrm>
           <a:prstGeom prst="rect">
             <a:avLst/>
@@ -4701,8 +4960,8 @@
         </p:nvSpPr>
         <p:spPr>
           <a:xfrm>
-            <a:off x="400000" y="6108000"/>
-            <a:ext cx="11392000" cy="600000"/>
+            <a:off x="411480" y="6309360"/>
+            <a:ext cx="11369040" cy="457200"/>
           </a:xfrm>
           <a:prstGeom prst="rect">
             <a:avLst/>
@@ -4716,10 +4975,17 @@
           <a:lstStyle/>
           <a:p>
             <a:pPr>
-              <a:defRPr sz="1100" i="1"/>
-            </a:pPr>
-            <a:r>
-              <a:t>Limits: multi-slice: no inter-segment axial flux, no end effects.</a:t>
+              <a:spcAft>
+                <a:spcPts val="500"/>
+              </a:spcAft>
+              <a:defRPr sz="1300" i="1" b="0">
+                <a:solidFill>
+                  <a:srgbClr val="555555"/>
+                </a:solidFill>
+              </a:defRPr>
+            </a:pPr>
+            <a:r>
+              <a:t>Limits: Hcj coefficient assumed (-0.55 %/K); static knee test; the Prius grade was not found in public sources: the bars compare candidate grades.</a:t>
             </a:r>
           </a:p>
         </p:txBody>
@@ -4750,8 +5016,8 @@
         </p:nvSpPr>
         <p:spPr>
           <a:xfrm>
-            <a:off x="400000" y="250000"/>
-            <a:ext cx="11392000" cy="700000"/>
+            <a:off x="411480" y="228600"/>
+            <a:ext cx="11369040" cy="640080"/>
           </a:xfrm>
           <a:prstGeom prst="rect">
             <a:avLst/>
@@ -4759,14 +5025,19 @@
           <a:noFill/>
         </p:spPr>
         <p:txBody>
-          <a:bodyPr wrap="none">
+          <a:bodyPr wrap="square">
             <a:spAutoFit/>
           </a:bodyPr>
           <a:lstStyle/>
           <a:p>
-            <a:r>
-              <a:rPr sz="2600" b="1"/>
-              <a:t>Manufacturing tolerances</a:t>
+            <a:pPr>
+              <a:spcAft>
+                <a:spcPts val="500"/>
+              </a:spcAft>
+              <a:defRPr sz="2800" i="0" b="1"/>
+            </a:pPr>
+            <a:r>
+              <a:t>Step skew</a:t>
             </a:r>
           </a:p>
         </p:txBody>
@@ -4779,8 +5050,8 @@
         </p:nvSpPr>
         <p:spPr>
           <a:xfrm>
-            <a:off x="400000" y="1000000"/>
-            <a:ext cx="11392000" cy="1570000"/>
+            <a:off x="411480" y="914400"/>
+            <a:ext cx="11369040" cy="1051560"/>
           </a:xfrm>
           <a:prstGeom prst="rect">
             <a:avLst/>
@@ -4795,52 +5066,30 @@
           <a:p>
             <a:pPr>
               <a:spcAft>
-                <a:spcPts val="400"/>
-              </a:spcAft>
-              <a:defRPr sz="1400"/>
-            </a:pPr>
-            <a:r>
-              <a:t>200 Monte-Carlo samples (JCGM 101), one nonlinear FEA each: remanence, magnet thickness and width, air gap.</a:t>
-            </a:r>
-          </a:p>
-          <a:p>
-            <a:pPr>
-              <a:spcAft>
-                <a:spcPts val="400"/>
-              </a:spcAft>
-              <a:defRPr sz="1400"/>
-            </a:pPr>
-            <a:r>
-              <a:t>Torque 343.3 +- 1.96 N m; ripple 20.2 +- 0.47 %.</a:t>
-            </a:r>
-          </a:p>
-          <a:p>
-            <a:pPr>
-              <a:spcAft>
-                <a:spcPts val="400"/>
-              </a:spcAft>
-              <a:defRPr sz="1400"/>
-            </a:pPr>
-            <a:r>
-              <a:t>Largest effects: remanence on torque (SRC 0.82), air gap on ripple (SRC -0.95); linear fits R^2 0.999 / 0.983.</a:t>
-            </a:r>
-          </a:p>
-          <a:p>
-            <a:pPr>
-              <a:spcAft>
-                <a:spcPts val="400"/>
-              </a:spcAft>
-              <a:defRPr sz="1400"/>
-            </a:pPr>
-            <a:r>
-              <a:t>Yield against the stated specification 1.000 (Wilson 95 %: 0.981 to 1.000).</a:t>
+                <a:spcPts val="500"/>
+              </a:spcAft>
+              <a:defRPr sz="1800" i="0" b="0"/>
+            </a:pPr>
+            <a:r>
+              <a:t>Two steps over 3.75 deg: cogging 1.35 -&gt; 0.62 N m (12 angles per slot pitch; R2 uses 24), ripple 22.9 -&gt; 8.8 %, R1 345.6 -&gt; 338.8 N m.</a:t>
+            </a:r>
+          </a:p>
+          <a:p>
+            <a:pPr>
+              <a:spcAft>
+                <a:spcPts val="500"/>
+              </a:spcAft>
+              <a:defRPr sz="1800" i="0" b="0"/>
+            </a:pPr>
+            <a:r>
+              <a:t>Back-EMF fundamental x0.9659 = closed-form skew factor 0.9659.</a:t>
             </a:r>
           </a:p>
         </p:txBody>
       </p:sp>
       <p:pic>
         <p:nvPicPr>
-          <p:cNvPr id="4" name="Picture 3" descr="17_prius_tolerances.png"/>
+          <p:cNvPr id="4" name="Picture 3" descr="image.png"/>
           <p:cNvPicPr>
             <a:picLocks noChangeAspect="1"/>
           </p:cNvPicPr>
@@ -4854,8 +5103,8 @@
         </p:blipFill>
         <p:spPr>
           <a:xfrm>
-            <a:off x="400000" y="2670000"/>
-            <a:ext cx="11392000" cy="3132800"/>
+            <a:off x="533565" y="2103120"/>
+            <a:ext cx="11124869" cy="4160520"/>
           </a:xfrm>
           <a:prstGeom prst="rect">
             <a:avLst/>
@@ -4870,8 +5119,8 @@
         </p:nvSpPr>
         <p:spPr>
           <a:xfrm>
-            <a:off x="400000" y="6108000"/>
-            <a:ext cx="11392000" cy="600000"/>
+            <a:off x="411480" y="6309360"/>
+            <a:ext cx="11369040" cy="457200"/>
           </a:xfrm>
           <a:prstGeom prst="rect">
             <a:avLst/>
@@ -4885,10 +5134,17 @@
           <a:lstStyle/>
           <a:p>
             <a:pPr>
-              <a:defRPr sz="1100" i="1"/>
-            </a:pPr>
-            <a:r>
-              <a:t>Limits: the tolerance sigmas are assumptions, not measured spreads.</a:t>
+              <a:spcAft>
+                <a:spcPts val="500"/>
+              </a:spcAft>
+              <a:defRPr sz="1300" i="1" b="0">
+                <a:solidFill>
+                  <a:srgbClr val="555555"/>
+                </a:solidFill>
+              </a:defRPr>
+            </a:pPr>
+            <a:r>
+              <a:t>Limits: multi-slice: no inter-segment axial flux, no end effects.</a:t>
             </a:r>
           </a:p>
         </p:txBody>

</xml_diff>